<commit_message>
Fix a caption overflow and two tight lines in the deck
</commit_message>
<xml_diff>
--- a/slides/Mandadi_Khalsa_Presentation1.pptx
+++ b/slides/Mandadi_Khalsa_Presentation1.pptx
@@ -4868,7 +4868,23 @@
                 </a:solidFill>
                 <a:latin typeface="Avenir Next"/>
               </a:rPr>
-              <a:t>Copper against its own expected range. The expected line uses only data from before the tariff.</a:t>
+              <a:t>Copper against its own expected range.</a:t>
+            </a:r>
+          </a:p>
+          <a:p>
+            <a:pPr algn="l">
+              <a:lnSpc>
+                <a:spcPct val="112000"/>
+              </a:lnSpc>
+            </a:pPr>
+            <a:r>
+              <a:rPr sz="1700" b="0" i="0">
+                <a:solidFill>
+                  <a:srgbClr val="6E737C"/>
+                </a:solidFill>
+                <a:latin typeface="Avenir Next"/>
+              </a:rPr>
+              <a:t>The expected line uses only data from before the tariff.</a:t>
             </a:r>
           </a:p>
         </p:txBody>
@@ -5870,7 +5886,7 @@
                 </a:solidFill>
                 <a:latin typeface="Avenir Next"/>
               </a:rPr>
-              <a:t>One row is one product, one country, one month.</a:t>
+              <a:t>One row: one product, one country, one month.</a:t>
             </a:r>
           </a:p>
         </p:txBody>
@@ -7243,7 +7259,23 @@
                 </a:solidFill>
                 <a:latin typeface="Avenir Next"/>
               </a:rPr>
-              <a:t>2,792 Federal Register documents reviewed, 134 are real tariff actions. Median gap from announcement to start date is 8 days.</a:t>
+              <a:t>2,792 Federal Register documents reviewed, 134 are real tariff actions.</a:t>
+            </a:r>
+          </a:p>
+          <a:p>
+            <a:pPr algn="l">
+              <a:lnSpc>
+                <a:spcPct val="112000"/>
+              </a:lnSpc>
+            </a:pPr>
+            <a:r>
+              <a:rPr sz="1700" b="0" i="0">
+                <a:solidFill>
+                  <a:srgbClr val="6E737C"/>
+                </a:solidFill>
+                <a:latin typeface="Avenir Next"/>
+              </a:rPr>
+              <a:t>Median gap from announcement to start date is 8 days.</a:t>
             </a:r>
           </a:p>
         </p:txBody>

</xml_diff>

<commit_message>
Put the six framing answers on the slides as labels, detail stays spoken
</commit_message>
<xml_diff>
--- a/slides/Mandadi_Khalsa_Presentation1.pptx
+++ b/slides/Mandadi_Khalsa_Presentation1.pptx
@@ -5335,6 +5335,22 @@
                 </a:solidFill>
                 <a:latin typeface="Avenir Next"/>
               </a:rPr>
+              <a:t>Importers, lenders and carriers all decide here.</a:t>
+            </a:r>
+          </a:p>
+          <a:p>
+            <a:pPr algn="l">
+              <a:lnSpc>
+                <a:spcPct val="112000"/>
+              </a:lnSpc>
+            </a:pPr>
+            <a:r>
+              <a:rPr sz="1700" b="0" i="0">
+                <a:solidFill>
+                  <a:srgbClr val="6E737C"/>
+                </a:solidFill>
+                <a:latin typeface="Avenir Next"/>
+              </a:rPr>
               <a:t>Census publishes monthly trade about five weeks after the month closes.</a:t>
             </a:r>
           </a:p>
@@ -5583,7 +5599,7 @@
                 </a:solidFill>
                 <a:latin typeface="Avenir Next"/>
               </a:rPr>
-              <a:t>Before the duty starts, do imports jump, and by how much?</a:t>
+              <a:t>classification, then regression</a:t>
             </a:r>
           </a:p>
         </p:txBody>
@@ -5661,9 +5677,32 @@
                 </a:solidFill>
                 <a:latin typeface="Avenir Next"/>
               </a:rPr>
-              <a:t>Is the drop volume borrowed from later months, a real fall in demand,</a:t>
-            </a:r>
-          </a:p>
+              <a:t>three-way classification: borrowed, lost, or relocated</a:t>
+            </a:r>
+          </a:p>
+        </p:txBody>
+      </p:sp>
+      <p:sp>
+        <p:nvSpPr>
+          <p:cNvPr id="10" name="TextBox 9"/>
+          <p:cNvSpPr txBox="1"/>
+          <p:nvPr/>
+        </p:nvSpPr>
+        <p:spPr>
+          <a:xfrm>
+            <a:off x="822960" y="3749039"/>
+            <a:ext cx="10360152" cy="731520"/>
+          </a:xfrm>
+          <a:prstGeom prst="rect">
+            <a:avLst/>
+          </a:prstGeom>
+          <a:noFill/>
+        </p:spPr>
+        <p:txBody>
+          <a:bodyPr wrap="square">
+            <a:spAutoFit/>
+          </a:bodyPr>
+          <a:lstStyle/>
           <a:p>
             <a:pPr algn="l">
               <a:lnSpc>
@@ -5671,26 +5710,26 @@
               </a:lnSpc>
             </a:pPr>
             <a:r>
-              <a:rPr sz="2000" b="0" i="0">
-                <a:solidFill>
-                  <a:srgbClr val="6E737C"/>
+              <a:rPr sz="2000" b="1" i="0">
+                <a:solidFill>
+                  <a:srgbClr val="14161A"/>
                 </a:solidFill>
                 <a:latin typeface="Avenir Next"/>
               </a:rPr>
-              <a:t>or trade moving to another country?</a:t>
-            </a:r>
-          </a:p>
-        </p:txBody>
-      </p:sp>
-      <p:sp>
-        <p:nvSpPr>
-          <p:cNvPr id="10" name="TextBox 9"/>
+              <a:t>3.  How long does it last?</a:t>
+            </a:r>
+          </a:p>
+        </p:txBody>
+      </p:sp>
+      <p:sp>
+        <p:nvSpPr>
+          <p:cNvPr id="11" name="TextBox 10"/>
           <p:cNvSpPr txBox="1"/>
           <p:nvPr/>
         </p:nvSpPr>
         <p:spPr>
           <a:xfrm>
-            <a:off x="822960" y="4041648"/>
+            <a:off x="822960" y="4206240"/>
             <a:ext cx="10360152" cy="731520"/>
           </a:xfrm>
           <a:prstGeom prst="rect">
@@ -5710,52 +5749,13 @@
               </a:lnSpc>
             </a:pPr>
             <a:r>
-              <a:rPr sz="2000" b="1" i="0">
-                <a:solidFill>
-                  <a:srgbClr val="14161A"/>
+              <a:rPr sz="2000" b="0" i="0">
+                <a:solidFill>
+                  <a:srgbClr val="6E737C"/>
                 </a:solidFill>
                 <a:latin typeface="Avenir Next"/>
               </a:rPr>
-              <a:t>3.  How long does it last?</a:t>
-            </a:r>
-          </a:p>
-        </p:txBody>
-      </p:sp>
-      <p:sp>
-        <p:nvSpPr>
-          <p:cNvPr id="11" name="TextBox 10"/>
-          <p:cNvSpPr txBox="1"/>
-          <p:nvPr/>
-        </p:nvSpPr>
-        <p:spPr>
-          <a:xfrm>
-            <a:off x="822960" y="4498848"/>
-            <a:ext cx="10360152" cy="731520"/>
-          </a:xfrm>
-          <a:prstGeom prst="rect">
-            <a:avLst/>
-          </a:prstGeom>
-          <a:noFill/>
-        </p:spPr>
-        <p:txBody>
-          <a:bodyPr wrap="square">
-            <a:spAutoFit/>
-          </a:bodyPr>
-          <a:lstStyle/>
-          <a:p>
-            <a:pPr algn="l">
-              <a:lnSpc>
-                <a:spcPct val="115000"/>
-              </a:lnSpc>
-            </a:pPr>
-            <a:r>
-              <a:rPr sz="2000" b="0" i="0">
-                <a:solidFill>
-                  <a:srgbClr val="6E737C"/>
-                </a:solidFill>
-                <a:latin typeface="Avenir Next"/>
-              </a:rPr>
-              <a:t>Months, or permanently?</a:t>
+              <a:t>duration, with censoring</a:t>
             </a:r>
           </a:p>
         </p:txBody>
@@ -6207,6 +6207,61 @@
         </p:nvSpPr>
         <p:spPr>
           <a:xfrm>
+            <a:off x="7040880" y="5138928"/>
+            <a:ext cx="4462272" cy="731520"/>
+          </a:xfrm>
+          <a:prstGeom prst="rect">
+            <a:avLst/>
+          </a:prstGeom>
+          <a:noFill/>
+        </p:spPr>
+        <p:txBody>
+          <a:bodyPr wrap="square">
+            <a:spAutoFit/>
+          </a:bodyPr>
+          <a:lstStyle/>
+          <a:p>
+            <a:pPr algn="l">
+              <a:lnSpc>
+                <a:spcPct val="125000"/>
+              </a:lnSpc>
+            </a:pPr>
+            <a:r>
+              <a:rPr sz="1200" b="1" i="0">
+                <a:solidFill>
+                  <a:srgbClr val="14161A"/>
+                </a:solidFill>
+                <a:latin typeface="Avenir Next"/>
+              </a:rPr>
+              <a:t>Census trade API  +  Federal Register API</a:t>
+            </a:r>
+          </a:p>
+          <a:p>
+            <a:pPr algn="l">
+              <a:lnSpc>
+                <a:spcPct val="125000"/>
+              </a:lnSpc>
+            </a:pPr>
+            <a:r>
+              <a:rPr sz="1200" b="1" i="0">
+                <a:solidFill>
+                  <a:srgbClr val="14161A"/>
+                </a:solidFill>
+                <a:latin typeface="Avenir Next"/>
+              </a:rPr>
+              <a:t>2,792 documents, 134 real tariff actions</a:t>
+            </a:r>
+          </a:p>
+        </p:txBody>
+      </p:sp>
+      <p:sp>
+        <p:nvSpPr>
+          <p:cNvPr id="11" name="TextBox 10"/>
+          <p:cNvSpPr txBox="1"/>
+          <p:nvPr/>
+        </p:nvSpPr>
+        <p:spPr>
+          <a:xfrm>
             <a:off x="685800" y="5897880"/>
             <a:ext cx="10817352" cy="822960"/>
           </a:xfrm>
@@ -6846,9 +6901,32 @@
                 </a:solidFill>
                 <a:latin typeface="Avenir Next"/>
               </a:rPr>
-              <a:t>140 months of imports at the exact level tariffs are written, reconciled</a:t>
-            </a:r>
-          </a:p>
+              <a:t>140 months at the level tariffs are written, reconciled against published totals.</a:t>
+            </a:r>
+          </a:p>
+        </p:txBody>
+      </p:sp>
+      <p:sp>
+        <p:nvSpPr>
+          <p:cNvPr id="7" name="TextBox 6"/>
+          <p:cNvSpPr txBox="1"/>
+          <p:nvPr/>
+        </p:nvSpPr>
+        <p:spPr>
+          <a:xfrm>
+            <a:off x="822960" y="2834640"/>
+            <a:ext cx="10360152" cy="731520"/>
+          </a:xfrm>
+          <a:prstGeom prst="rect">
+            <a:avLst/>
+          </a:prstGeom>
+          <a:noFill/>
+        </p:spPr>
+        <p:txBody>
+          <a:bodyPr wrap="square">
+            <a:spAutoFit/>
+          </a:bodyPr>
+          <a:lstStyle/>
           <a:p>
             <a:pPr algn="l">
               <a:lnSpc>
@@ -6856,26 +6934,26 @@
               </a:lnSpc>
             </a:pPr>
             <a:r>
-              <a:rPr sz="1700" b="0" i="0">
-                <a:solidFill>
-                  <a:srgbClr val="6E737C"/>
+              <a:rPr sz="1700" b="1" i="0">
+                <a:solidFill>
+                  <a:srgbClr val="14161A"/>
                 </a:solidFill>
                 <a:latin typeface="Avenir Next"/>
               </a:rPr>
-              <a:t>against published totals.</a:t>
-            </a:r>
-          </a:p>
-        </p:txBody>
-      </p:sp>
-      <p:sp>
-        <p:nvSpPr>
-          <p:cNvPr id="7" name="TextBox 6"/>
+              <a:t>A detector, and its limits</a:t>
+            </a:r>
+          </a:p>
+        </p:txBody>
+      </p:sp>
+      <p:sp>
+        <p:nvSpPr>
+          <p:cNvPr id="8" name="TextBox 7"/>
           <p:cNvSpPr txBox="1"/>
           <p:nvPr/>
         </p:nvSpPr>
         <p:spPr>
           <a:xfrm>
-            <a:off x="822960" y="3127248"/>
+            <a:off x="822960" y="3291840"/>
             <a:ext cx="10360152" cy="731520"/>
           </a:xfrm>
           <a:prstGeom prst="rect">
@@ -6895,26 +6973,26 @@
               </a:lnSpc>
             </a:pPr>
             <a:r>
-              <a:rPr sz="1700" b="1" i="0">
-                <a:solidFill>
-                  <a:srgbClr val="14161A"/>
+              <a:rPr sz="1700" b="0" i="0">
+                <a:solidFill>
+                  <a:srgbClr val="6E737C"/>
                 </a:solidFill>
                 <a:latin typeface="Avenir Next"/>
               </a:rPr>
-              <a:t>A detector, and its limits</a:t>
-            </a:r>
-          </a:p>
-        </p:txBody>
-      </p:sp>
-      <p:sp>
-        <p:nvSpPr>
-          <p:cNvPr id="8" name="TextBox 7"/>
+              <a:t>It finds unusual months. It cannot tell a tariff from a price shock.</a:t>
+            </a:r>
+          </a:p>
+        </p:txBody>
+      </p:sp>
+      <p:sp>
+        <p:nvSpPr>
+          <p:cNvPr id="9" name="TextBox 8"/>
           <p:cNvSpPr txBox="1"/>
           <p:nvPr/>
         </p:nvSpPr>
         <p:spPr>
           <a:xfrm>
-            <a:off x="822960" y="3584448"/>
+            <a:off x="822960" y="3749039"/>
             <a:ext cx="10360152" cy="731520"/>
           </a:xfrm>
           <a:prstGeom prst="rect">
@@ -6934,15 +7012,38 @@
               </a:lnSpc>
             </a:pPr>
             <a:r>
-              <a:rPr sz="1700" b="0" i="0">
-                <a:solidFill>
-                  <a:srgbClr val="6E737C"/>
+              <a:rPr sz="1700" b="1" i="0">
+                <a:solidFill>
+                  <a:srgbClr val="14161A"/>
                 </a:solidFill>
                 <a:latin typeface="Avenir Next"/>
               </a:rPr>
-              <a:t>We can find months that are unusual for a product, and we know it cannot</a:t>
-            </a:r>
-          </a:p>
+              <a:t>134 tariff actions, with the products behind each one</a:t>
+            </a:r>
+          </a:p>
+        </p:txBody>
+      </p:sp>
+      <p:sp>
+        <p:nvSpPr>
+          <p:cNvPr id="10" name="TextBox 9"/>
+          <p:cNvSpPr txBox="1"/>
+          <p:nvPr/>
+        </p:nvSpPr>
+        <p:spPr>
+          <a:xfrm>
+            <a:off x="822960" y="4206240"/>
+            <a:ext cx="10360152" cy="731520"/>
+          </a:xfrm>
+          <a:prstGeom prst="rect">
+            <a:avLst/>
+          </a:prstGeom>
+          <a:noFill/>
+        </p:spPr>
+        <p:txBody>
+          <a:bodyPr wrap="square">
+            <a:spAutoFit/>
+          </a:bodyPr>
+          <a:lstStyle/>
           <a:p>
             <a:pPr algn="l">
               <a:lnSpc>
@@ -6956,20 +7057,20 @@
                 </a:solidFill>
                 <a:latin typeface="Avenir Next"/>
               </a:rPr>
-              <a:t>tell a tariff from a price shock on its own.</a:t>
-            </a:r>
-          </a:p>
-        </p:txBody>
-      </p:sp>
-      <p:sp>
-        <p:nvSpPr>
-          <p:cNvPr id="9" name="TextBox 8"/>
+              <a:t>Corrected dates, and the 8-digit product lists.</a:t>
+            </a:r>
+          </a:p>
+        </p:txBody>
+      </p:sp>
+      <p:sp>
+        <p:nvSpPr>
+          <p:cNvPr id="11" name="TextBox 10"/>
           <p:cNvSpPr txBox="1"/>
           <p:nvPr/>
         </p:nvSpPr>
         <p:spPr>
           <a:xfrm>
-            <a:off x="822960" y="4334256"/>
+            <a:off x="822960" y="4663440"/>
             <a:ext cx="10360152" cy="731520"/>
           </a:xfrm>
           <a:prstGeom prst="rect">
@@ -6995,20 +7096,20 @@
                 </a:solidFill>
                 <a:latin typeface="Avenir Next"/>
               </a:rPr>
-              <a:t>134 tariff actions, with the products behind each one</a:t>
-            </a:r>
-          </a:p>
-        </p:txBody>
-      </p:sp>
-      <p:sp>
-        <p:nvSpPr>
-          <p:cNvPr id="10" name="TextBox 9"/>
+              <a:t>How we will measure it</a:t>
+            </a:r>
+          </a:p>
+        </p:txBody>
+      </p:sp>
+      <p:sp>
+        <p:nvSpPr>
+          <p:cNvPr id="12" name="TextBox 11"/>
           <p:cNvSpPr txBox="1"/>
           <p:nvPr/>
         </p:nvSpPr>
         <p:spPr>
           <a:xfrm>
-            <a:off x="822960" y="4791456"/>
+            <a:off x="822960" y="5120640"/>
             <a:ext cx="10360152" cy="731520"/>
           </a:xfrm>
           <a:prstGeom prst="rect">
@@ -7034,20 +7135,20 @@
                 </a:solidFill>
                 <a:latin typeface="Avenir Next"/>
               </a:rPr>
-              <a:t>Corrected announcement and effective dates, and the 8-digit product lists.</a:t>
-            </a:r>
-          </a:p>
-        </p:txBody>
-      </p:sp>
-      <p:sp>
-        <p:nvSpPr>
-          <p:cNvPr id="11" name="TextBox 10"/>
+              <a:t>Within product, across origins.</a:t>
+            </a:r>
+          </a:p>
+        </p:txBody>
+      </p:sp>
+      <p:sp>
+        <p:nvSpPr>
+          <p:cNvPr id="13" name="TextBox 12"/>
           <p:cNvSpPr txBox="1"/>
           <p:nvPr/>
         </p:nvSpPr>
         <p:spPr>
           <a:xfrm>
-            <a:off x="822960" y="5248656"/>
+            <a:off x="822960" y="5577840"/>
             <a:ext cx="10360152" cy="731520"/>
           </a:xfrm>
           <a:prstGeom prst="rect">
@@ -7073,20 +7174,20 @@
                 </a:solidFill>
                 <a:latin typeface="Avenir Next"/>
               </a:rPr>
-              <a:t>Next</a:t>
-            </a:r>
-          </a:p>
-        </p:txBody>
-      </p:sp>
-      <p:sp>
-        <p:nvSpPr>
-          <p:cNvPr id="12" name="TextBox 11"/>
+              <a:t>How we will know it is real</a:t>
+            </a:r>
+          </a:p>
+        </p:txBody>
+      </p:sp>
+      <p:sp>
+        <p:nvSpPr>
+          <p:cNvPr id="14" name="TextBox 13"/>
           <p:cNvSpPr txBox="1"/>
           <p:nvPr/>
         </p:nvSpPr>
         <p:spPr>
           <a:xfrm>
-            <a:off x="822960" y="5705856"/>
+            <a:off x="822960" y="6035040"/>
             <a:ext cx="10360152" cy="731520"/>
           </a:xfrm>
           <a:prstGeom prst="rect">
@@ -7112,23 +7213,7 @@
                 </a:solidFill>
                 <a:latin typeface="Avenir Next"/>
               </a:rPr>
-              <a:t>Measure the rush and what follows it, at product level, using untreated</a:t>
-            </a:r>
-          </a:p>
-          <a:p>
-            <a:pPr algn="l">
-              <a:lnSpc>
-                <a:spcPct val="115000"/>
-              </a:lnSpc>
-            </a:pPr>
-            <a:r>
-              <a:rPr sz="1700" b="0" i="0">
-                <a:solidFill>
-                  <a:srgbClr val="6E737C"/>
-                </a:solidFill>
-                <a:latin typeface="Avenir Next"/>
-              </a:rPr>
-              <a:t>countries as the comparison.</a:t>
+              <a:t>Every estimate against a placebo. Three methods have already failed it.</a:t>
             </a:r>
           </a:p>
         </p:txBody>

</xml_diff>

<commit_message>
Number all figures and tables, add the actionable take-away
</commit_message>
<xml_diff>
--- a/slides/Mandadi_Khalsa_Presentation1.pptx
+++ b/slides/Mandadi_Khalsa_Presentation1.pptx
@@ -4931,23 +4931,7 @@
                 </a:solidFill>
                 <a:latin typeface="Avenir Next"/>
               </a:rPr>
-              <a:t>Copper against its own expected range.</a:t>
-            </a:r>
-          </a:p>
-          <a:p>
-            <a:pPr algn="l">
-              <a:lnSpc>
-                <a:spcPct val="112000"/>
-              </a:lnSpc>
-            </a:pPr>
-            <a:r>
-              <a:rPr sz="1700" b="0" i="0">
-                <a:solidFill>
-                  <a:srgbClr val="6E737C"/>
-                </a:solidFill>
-                <a:latin typeface="Avenir Next"/>
-              </a:rPr>
-              <a:t>The expected line uses only data from before the tariff.</a:t>
+              <a:t>Fig. 7   Copper against its own expected range, built only from data before the tariff.</a:t>
             </a:r>
           </a:p>
         </p:txBody>
@@ -5141,7 +5125,23 @@
                 </a:solidFill>
                 <a:latin typeface="Avenir Next"/>
               </a:rPr>
-              <a:t>A duty is announced, then starts later. That gap is a window to import before it applies.</a:t>
+              <a:t>Fig. 1   Copper imports. A duty is announced, then starts later.</a:t>
+            </a:r>
+          </a:p>
+          <a:p>
+            <a:pPr algn="l">
+              <a:lnSpc>
+                <a:spcPct val="112000"/>
+              </a:lnSpc>
+            </a:pPr>
+            <a:r>
+              <a:rPr sz="1700" b="0" i="0">
+                <a:solidFill>
+                  <a:srgbClr val="6E737C"/>
+                </a:solidFill>
+                <a:latin typeface="Avenir Next"/>
+              </a:rPr>
+              <a:t>That gap is a window to import before it applies.</a:t>
             </a:r>
           </a:p>
         </p:txBody>
@@ -5335,7 +5335,7 @@
                 </a:solidFill>
                 <a:latin typeface="Avenir Next"/>
               </a:rPr>
-              <a:t>Importers, lenders and carriers all decide here.</a:t>
+              <a:t>Fig. 2   Importers, lenders and carriers all decide here.</a:t>
             </a:r>
           </a:p>
           <a:p>
@@ -5949,7 +5949,7 @@
                 </a:solidFill>
                 <a:latin typeface="Avenir Next"/>
               </a:rPr>
-              <a:t>One row: one product, one country, one month.</a:t>
+              <a:t>Table 1   One product, one country, one month.</a:t>
             </a:r>
           </a:p>
         </p:txBody>
@@ -6288,7 +6288,7 @@
                 </a:solidFill>
                 <a:latin typeface="Avenir Next"/>
               </a:rPr>
-              <a:t>2017 adds up to 2,340 billion dollars against a published 2.34 trillion, and all 140 months</a:t>
+              <a:t>Fig. 3   2017 adds up to 2,340 billion dollars against a published 2.34 trillion, and all</a:t>
             </a:r>
           </a:p>
           <a:p>
@@ -6304,7 +6304,7 @@
                 </a:solidFill>
                 <a:latin typeface="Avenir Next"/>
               </a:rPr>
-              <a:t>reconcile against a separate total the API returns on its own.</a:t>
+              <a:t>140 months reconcile against a separate total the API returns on its own.</a:t>
             </a:r>
           </a:p>
         </p:txBody>
@@ -6498,7 +6498,7 @@
                 </a:solidFill>
                 <a:latin typeface="Avenir Next"/>
               </a:rPr>
-              <a:t>Each chapter measured against its own normal range, built only from data before 2025.</a:t>
+              <a:t>Fig. 4   Each chapter measured against its own normal range, built only from data before 2025.</a:t>
             </a:r>
           </a:p>
         </p:txBody>
@@ -6692,7 +6692,7 @@
                 </a:solidFill>
                 <a:latin typeface="Avenir Next"/>
               </a:rPr>
-              <a:t>The typical tariff action covers about 5% of its chapter's value. A third cover under 1%.</a:t>
+              <a:t>Fig. 5   The typical tariff action covers about 5% of its chapter's value. A third cover under 1%.</a:t>
             </a:r>
           </a:p>
         </p:txBody>
@@ -6836,6 +6836,61 @@
         </p:nvSpPr>
         <p:spPr>
           <a:xfrm>
+            <a:off x="685800" y="5897880"/>
+            <a:ext cx="10817352" cy="685800"/>
+          </a:xfrm>
+          <a:prstGeom prst="rect">
+            <a:avLst/>
+          </a:prstGeom>
+          <a:noFill/>
+        </p:spPr>
+        <p:txBody>
+          <a:bodyPr wrap="square">
+            <a:spAutoFit/>
+          </a:bodyPr>
+          <a:lstStyle/>
+          <a:p>
+            <a:pPr algn="l">
+              <a:lnSpc>
+                <a:spcPct val="112000"/>
+              </a:lnSpc>
+            </a:pPr>
+            <a:r>
+              <a:rPr sz="1700" b="0" i="0">
+                <a:solidFill>
+                  <a:srgbClr val="6E737C"/>
+                </a:solidFill>
+                <a:latin typeface="Avenir Next"/>
+              </a:rPr>
+              <a:t>Take-away for anyone working with this data: do not measure tariff effects at chapter level.</a:t>
+            </a:r>
+          </a:p>
+          <a:p>
+            <a:pPr algn="l">
+              <a:lnSpc>
+                <a:spcPct val="112000"/>
+              </a:lnSpc>
+            </a:pPr>
+            <a:r>
+              <a:rPr sz="1700" b="0" i="0">
+                <a:solidFill>
+                  <a:srgbClr val="6E737C"/>
+                </a:solidFill>
+                <a:latin typeface="Avenir Next"/>
+              </a:rPr>
+              <a:t>The typical action touches 5% of a chapter, so a real effect averages away to nothing.</a:t>
+            </a:r>
+          </a:p>
+        </p:txBody>
+      </p:sp>
+      <p:sp>
+        <p:nvSpPr>
+          <p:cNvPr id="6" name="TextBox 5"/>
+          <p:cNvSpPr txBox="1"/>
+          <p:nvPr/>
+        </p:nvSpPr>
+        <p:spPr>
+          <a:xfrm>
             <a:off x="822960" y="1920240"/>
             <a:ext cx="10360152" cy="731520"/>
           </a:xfrm>
@@ -6869,7 +6924,7 @@
       </p:sp>
       <p:sp>
         <p:nvSpPr>
-          <p:cNvPr id="6" name="TextBox 5"/>
+          <p:cNvPr id="7" name="TextBox 6"/>
           <p:cNvSpPr txBox="1"/>
           <p:nvPr/>
         </p:nvSpPr>
@@ -6908,7 +6963,7 @@
       </p:sp>
       <p:sp>
         <p:nvSpPr>
-          <p:cNvPr id="7" name="TextBox 6"/>
+          <p:cNvPr id="8" name="TextBox 7"/>
           <p:cNvSpPr txBox="1"/>
           <p:nvPr/>
         </p:nvSpPr>
@@ -6947,7 +7002,7 @@
       </p:sp>
       <p:sp>
         <p:nvSpPr>
-          <p:cNvPr id="8" name="TextBox 7"/>
+          <p:cNvPr id="9" name="TextBox 8"/>
           <p:cNvSpPr txBox="1"/>
           <p:nvPr/>
         </p:nvSpPr>
@@ -6986,7 +7041,7 @@
       </p:sp>
       <p:sp>
         <p:nvSpPr>
-          <p:cNvPr id="9" name="TextBox 8"/>
+          <p:cNvPr id="10" name="TextBox 9"/>
           <p:cNvSpPr txBox="1"/>
           <p:nvPr/>
         </p:nvSpPr>
@@ -7025,7 +7080,7 @@
       </p:sp>
       <p:sp>
         <p:nvSpPr>
-          <p:cNvPr id="10" name="TextBox 9"/>
+          <p:cNvPr id="11" name="TextBox 10"/>
           <p:cNvSpPr txBox="1"/>
           <p:nvPr/>
         </p:nvSpPr>
@@ -7064,7 +7119,7 @@
       </p:sp>
       <p:sp>
         <p:nvSpPr>
-          <p:cNvPr id="11" name="TextBox 10"/>
+          <p:cNvPr id="12" name="TextBox 11"/>
           <p:cNvSpPr txBox="1"/>
           <p:nvPr/>
         </p:nvSpPr>
@@ -7103,7 +7158,7 @@
       </p:sp>
       <p:sp>
         <p:nvSpPr>
-          <p:cNvPr id="12" name="TextBox 11"/>
+          <p:cNvPr id="13" name="TextBox 12"/>
           <p:cNvSpPr txBox="1"/>
           <p:nvPr/>
         </p:nvSpPr>
@@ -7142,7 +7197,7 @@
       </p:sp>
       <p:sp>
         <p:nvSpPr>
-          <p:cNvPr id="13" name="TextBox 12"/>
+          <p:cNvPr id="14" name="TextBox 13"/>
           <p:cNvSpPr txBox="1"/>
           <p:nvPr/>
         </p:nvSpPr>
@@ -7181,7 +7236,7 @@
       </p:sp>
       <p:sp>
         <p:nvSpPr>
-          <p:cNvPr id="14" name="TextBox 13"/>
+          <p:cNvPr id="15" name="TextBox 14"/>
           <p:cNvSpPr txBox="1"/>
           <p:nvPr/>
         </p:nvSpPr>
@@ -7407,7 +7462,7 @@
                 </a:solidFill>
                 <a:latin typeface="Avenir Next"/>
               </a:rPr>
-              <a:t>2,792 Federal Register documents reviewed, 134 are real tariff actions.</a:t>
+              <a:t>Fig. 6   2,792 Federal Register documents reviewed, 134 are real tariff actions.</a:t>
             </a:r>
           </a:p>
           <a:p>

</xml_diff>

<commit_message>
Add verified literature context and a references backup slide
</commit_message>
<xml_diff>
--- a/slides/Mandadi_Khalsa_Presentation1.pptx
+++ b/slides/Mandadi_Khalsa_Presentation1.pptx
@@ -15,6 +15,7 @@
     <p:sldId id="263" r:id="rId15"/>
     <p:sldId id="264" r:id="rId16"/>
     <p:sldId id="265" r:id="rId17"/>
+    <p:sldId id="266" r:id="rId18"/>
   </p:sldIdLst>
   <p:sldSz cx="12191695" cy="6858000" type="screen4x3"/>
   <p:notesSz cx="6858000" cy="9144000"/>
@@ -657,6 +658,100 @@
           <a:p>
             <a:r>
               <a:t>Aluminium does NOT clear: it peaks at 26% against a band of 100%, because its own history is volatile. Same tariff year, and the test says no. A test that can say no is the only kind worth having.</a:t>
+            </a:r>
+          </a:p>
+        </p:txBody>
+      </p:sp>
+      <p:sp>
+        <p:nvSpPr>
+          <p:cNvPr id="4" name="Slide Number Placeholder 3"/>
+          <p:cNvSpPr>
+            <a:spLocks noGrp="1"/>
+          </p:cNvSpPr>
+          <p:nvPr>
+            <p:ph type="sldNum" idx="5" sz="quarter"/>
+          </p:nvPr>
+        </p:nvSpPr>
+        <p:spPr/>
+      </p:sp>
+    </p:spTree>
+  </p:cSld>
+  <p:clrMapOvr>
+    <a:masterClrMapping/>
+  </p:clrMapOvr>
+</p:notes>
+</file>
+
+<file path=ppt/notesSlides/notesSlide11.xml><?xml version="1.0" encoding="utf-8"?>
+<p:notes xmlns:a="http://schemas.openxmlformats.org/drawingml/2006/main" xmlns:p="http://schemas.openxmlformats.org/presentationml/2006/main" xmlns:r="http://schemas.openxmlformats.org/officeDocument/2006/relationships">
+  <p:cSld>
+    <p:spTree>
+      <p:nvGrpSpPr>
+        <p:cNvPr id="1" name=""/>
+        <p:cNvGrpSpPr/>
+        <p:nvPr/>
+      </p:nvGrpSpPr>
+      <p:grpSpPr>
+        <a:xfrm>
+          <a:off x="0" y="0"/>
+          <a:ext cx="0" cy="0"/>
+          <a:chOff x="0" y="0"/>
+          <a:chExt cx="0" cy="0"/>
+        </a:xfrm>
+      </p:grpSpPr>
+      <p:sp>
+        <p:nvSpPr>
+          <p:cNvPr id="2" name="Slide Image Placeholder 1"/>
+          <p:cNvSpPr>
+            <a:spLocks noGrp="1"/>
+          </p:cNvSpPr>
+          <p:nvPr>
+            <p:ph type="sldImg" idx="2"/>
+          </p:nvPr>
+        </p:nvSpPr>
+        <p:spPr/>
+      </p:sp>
+      <p:sp>
+        <p:nvSpPr>
+          <p:cNvPr id="3" name="Notes Placeholder 2"/>
+          <p:cNvSpPr>
+            <a:spLocks noGrp="1"/>
+          </p:cNvSpPr>
+          <p:nvPr>
+            <p:ph type="body" idx="3" sz="quarter"/>
+          </p:nvPr>
+        </p:nvSpPr>
+        <p:spPr/>
+        <p:txBody>
+          <a:bodyPr/>
+          <a:lstStyle/>
+          <a:p>
+            <a:r>
+              <a:t>BACKUP, not part of the talk. Use if asked about prior work.</a:t>
+            </a:r>
+          </a:p>
+          <a:p/>
+          <a:p>
+            <a:r>
+              <a:t>The two that matter: [1] is the frontier paper on this exact shock and it works at HS-10, stating that the 2018 tariff increases were 'predominantly set at the 8-digit Harmonized System level'. That is why we pull at HS10 and analyse at HS8.</a:t>
+            </a:r>
+          </a:p>
+          <a:p/>
+          <a:p>
+            <a:r>
+              <a:t>[2] is USITC's own work estimating the same elasticity at HTS 2, 4, 6 and 8 digits and finding that estimates from aggregated data are smaller, which they attribute to heterogeneity bias. Our 5% number is the specific version of that general result.</a:t>
+            </a:r>
+          </a:p>
+          <a:p/>
+          <a:p>
+            <a:r>
+              <a:t>[4] faced the same problem and solved it the way we did: a continuous value-weighted coverage share instead of a binary tariffed/not flag.</a:t>
+            </a:r>
+          </a:p>
+          <a:p/>
+          <a:p>
+            <a:r>
+              <a:t>Worth saying plainly if asked: nobody appears to have published the specific diagnostic we ran, which is to assign treatment at chapter level when the tariff names HS8 and measure how much of the chapter that actually covers. The general attenuation result is known; the number for US tariff actions is ours.</a:t>
             </a:r>
           </a:p>
         </p:txBody>
@@ -4944,6 +5039,644 @@
 </p:sld>
 </file>
 
+<file path=ppt/slides/slide11.xml><?xml version="1.0" encoding="utf-8"?>
+<p:sld xmlns:a="http://schemas.openxmlformats.org/drawingml/2006/main" xmlns:p="http://schemas.openxmlformats.org/presentationml/2006/main" xmlns:r="http://schemas.openxmlformats.org/officeDocument/2006/relationships">
+  <p:cSld>
+    <p:spTree>
+      <p:nvGrpSpPr>
+        <p:cNvPr id="1" name=""/>
+        <p:cNvGrpSpPr/>
+        <p:nvPr/>
+      </p:nvGrpSpPr>
+      <p:grpSpPr/>
+      <p:sp>
+        <p:nvSpPr>
+          <p:cNvPr id="2" name="TextBox 1"/>
+          <p:cNvSpPr txBox="1"/>
+          <p:nvPr/>
+        </p:nvSpPr>
+        <p:spPr>
+          <a:xfrm>
+            <a:off x="5486400" y="292608"/>
+            <a:ext cx="6016752" cy="274320"/>
+          </a:xfrm>
+          <a:prstGeom prst="rect">
+            <a:avLst/>
+          </a:prstGeom>
+          <a:noFill/>
+        </p:spPr>
+        <p:txBody>
+          <a:bodyPr wrap="square">
+            <a:spAutoFit/>
+          </a:bodyPr>
+          <a:lstStyle/>
+          <a:p>
+            <a:pPr algn="r">
+              <a:lnSpc>
+                <a:spcPct val="100000"/>
+              </a:lnSpc>
+            </a:pPr>
+            <a:r>
+              <a:rPr sz="900" b="0" i="0">
+                <a:solidFill>
+                  <a:srgbClr val="6E737C"/>
+                </a:solidFill>
+                <a:latin typeface="Avenir Next"/>
+              </a:rPr>
+              <a:t>RAHUL REDDY MANDADI   +   RAUNAKSINGH KHALSA</a:t>
+            </a:r>
+          </a:p>
+        </p:txBody>
+      </p:sp>
+      <p:cxnSp>
+        <p:nvCxnSpPr>
+          <p:cNvPr id="3" name="Connector 2"/>
+          <p:cNvCxnSpPr/>
+          <p:nvPr/>
+        </p:nvCxnSpPr>
+        <p:spPr>
+          <a:xfrm>
+            <a:off x="685800" y="676656"/>
+            <a:ext cx="10817352" cy="0"/>
+          </a:xfrm>
+          <a:prstGeom prst="line">
+            <a:avLst/>
+          </a:prstGeom>
+          <a:ln w="9525">
+            <a:solidFill>
+              <a:srgbClr val="6E737C"/>
+            </a:solidFill>
+          </a:ln>
+        </p:spPr>
+        <p:style>
+          <a:lnRef idx="2">
+            <a:schemeClr val="accent1"/>
+          </a:lnRef>
+          <a:fillRef idx="0">
+            <a:schemeClr val="accent1"/>
+          </a:fillRef>
+          <a:effectRef idx="1">
+            <a:schemeClr val="accent1"/>
+          </a:effectRef>
+          <a:fontRef idx="minor">
+            <a:schemeClr val="tx1"/>
+          </a:fontRef>
+        </p:style>
+      </p:cxnSp>
+      <p:sp>
+        <p:nvSpPr>
+          <p:cNvPr id="4" name="TextBox 3"/>
+          <p:cNvSpPr txBox="1"/>
+          <p:nvPr/>
+        </p:nvSpPr>
+        <p:spPr>
+          <a:xfrm>
+            <a:off x="685800" y="868680"/>
+            <a:ext cx="10817352" cy="731520"/>
+          </a:xfrm>
+          <a:prstGeom prst="rect">
+            <a:avLst/>
+          </a:prstGeom>
+          <a:noFill/>
+        </p:spPr>
+        <p:txBody>
+          <a:bodyPr wrap="square">
+            <a:spAutoFit/>
+          </a:bodyPr>
+          <a:lstStyle/>
+          <a:p>
+            <a:pPr algn="l">
+              <a:lnSpc>
+                <a:spcPct val="100000"/>
+              </a:lnSpc>
+            </a:pPr>
+            <a:r>
+              <a:rPr sz="3800" b="1" i="0">
+                <a:solidFill>
+                  <a:srgbClr val="14161A"/>
+                </a:solidFill>
+                <a:latin typeface="Avenir Next"/>
+              </a:rPr>
+              <a:t>Backup: references.</a:t>
+            </a:r>
+          </a:p>
+        </p:txBody>
+      </p:sp>
+      <p:sp>
+        <p:nvSpPr>
+          <p:cNvPr id="5" name="TextBox 4"/>
+          <p:cNvSpPr txBox="1"/>
+          <p:nvPr/>
+        </p:nvSpPr>
+        <p:spPr>
+          <a:xfrm>
+            <a:off x="685800" y="1783080"/>
+            <a:ext cx="10817352" cy="310896"/>
+          </a:xfrm>
+          <a:prstGeom prst="rect">
+            <a:avLst/>
+          </a:prstGeom>
+          <a:noFill/>
+        </p:spPr>
+        <p:txBody>
+          <a:bodyPr wrap="square">
+            <a:spAutoFit/>
+          </a:bodyPr>
+          <a:lstStyle/>
+          <a:p>
+            <a:pPr algn="l">
+              <a:lnSpc>
+                <a:spcPct val="100000"/>
+              </a:lnSpc>
+            </a:pPr>
+            <a:r>
+              <a:rPr sz="1300" b="0" i="0">
+                <a:solidFill>
+                  <a:srgbClr val="14161A"/>
+                </a:solidFill>
+                <a:latin typeface="Avenir Next"/>
+              </a:rPr>
+              <a:t>[1]  Fajgelbaum, P., Goldberg, P., Kennedy, P. and Khandelwal, A. (2020). The Return to</a:t>
+            </a:r>
+          </a:p>
+        </p:txBody>
+      </p:sp>
+      <p:sp>
+        <p:nvSpPr>
+          <p:cNvPr id="6" name="TextBox 5"/>
+          <p:cNvSpPr txBox="1"/>
+          <p:nvPr/>
+        </p:nvSpPr>
+        <p:spPr>
+          <a:xfrm>
+            <a:off x="685800" y="2057400"/>
+            <a:ext cx="10817352" cy="310896"/>
+          </a:xfrm>
+          <a:prstGeom prst="rect">
+            <a:avLst/>
+          </a:prstGeom>
+          <a:noFill/>
+        </p:spPr>
+        <p:txBody>
+          <a:bodyPr wrap="square">
+            <a:spAutoFit/>
+          </a:bodyPr>
+          <a:lstStyle/>
+          <a:p>
+            <a:pPr algn="l">
+              <a:lnSpc>
+                <a:spcPct val="100000"/>
+              </a:lnSpc>
+            </a:pPr>
+            <a:r>
+              <a:rPr sz="1300" b="0" i="0">
+                <a:solidFill>
+                  <a:srgbClr val="6E737C"/>
+                </a:solidFill>
+                <a:latin typeface="Avenir Next"/>
+              </a:rPr>
+              <a:t>       Protectionism. Quarterly Journal of Economics 135(1), 1-55.</a:t>
+            </a:r>
+          </a:p>
+        </p:txBody>
+      </p:sp>
+      <p:sp>
+        <p:nvSpPr>
+          <p:cNvPr id="7" name="TextBox 6"/>
+          <p:cNvSpPr txBox="1"/>
+          <p:nvPr/>
+        </p:nvSpPr>
+        <p:spPr>
+          <a:xfrm>
+            <a:off x="685800" y="2331720"/>
+            <a:ext cx="10817352" cy="310896"/>
+          </a:xfrm>
+          <a:prstGeom prst="rect">
+            <a:avLst/>
+          </a:prstGeom>
+          <a:noFill/>
+        </p:spPr>
+        <p:txBody>
+          <a:bodyPr wrap="square">
+            <a:spAutoFit/>
+          </a:bodyPr>
+          <a:lstStyle/>
+          <a:p>
+            <a:pPr algn="l">
+              <a:lnSpc>
+                <a:spcPct val="100000"/>
+              </a:lnSpc>
+            </a:pPr>
+            <a:r>
+              <a:rPr sz="1300" b="0" i="0">
+                <a:solidFill>
+                  <a:srgbClr val="14161A"/>
+                </a:solidFill>
+                <a:latin typeface="Avenir Next"/>
+              </a:rPr>
+              <a:t>[2]  Schrammel, M. and Schreiber, S. (2023). How Does Data Aggregation Impact Elasticity of</a:t>
+            </a:r>
+          </a:p>
+        </p:txBody>
+      </p:sp>
+      <p:sp>
+        <p:nvSpPr>
+          <p:cNvPr id="8" name="TextBox 7"/>
+          <p:cNvSpPr txBox="1"/>
+          <p:nvPr/>
+        </p:nvSpPr>
+        <p:spPr>
+          <a:xfrm>
+            <a:off x="685800" y="2606039"/>
+            <a:ext cx="10817352" cy="310896"/>
+          </a:xfrm>
+          <a:prstGeom prst="rect">
+            <a:avLst/>
+          </a:prstGeom>
+          <a:noFill/>
+        </p:spPr>
+        <p:txBody>
+          <a:bodyPr wrap="square">
+            <a:spAutoFit/>
+          </a:bodyPr>
+          <a:lstStyle/>
+          <a:p>
+            <a:pPr algn="l">
+              <a:lnSpc>
+                <a:spcPct val="100000"/>
+              </a:lnSpc>
+            </a:pPr>
+            <a:r>
+              <a:rPr sz="1300" b="0" i="0">
+                <a:solidFill>
+                  <a:srgbClr val="6E737C"/>
+                </a:solidFill>
+                <a:latin typeface="Avenir Next"/>
+              </a:rPr>
+              <a:t>       Substitution Estimation? USITC Economics Working Paper 2023-10-B.</a:t>
+            </a:r>
+          </a:p>
+        </p:txBody>
+      </p:sp>
+      <p:sp>
+        <p:nvSpPr>
+          <p:cNvPr id="9" name="TextBox 8"/>
+          <p:cNvSpPr txBox="1"/>
+          <p:nvPr/>
+        </p:nvSpPr>
+        <p:spPr>
+          <a:xfrm>
+            <a:off x="685800" y="2880359"/>
+            <a:ext cx="10817352" cy="310896"/>
+          </a:xfrm>
+          <a:prstGeom prst="rect">
+            <a:avLst/>
+          </a:prstGeom>
+          <a:noFill/>
+        </p:spPr>
+        <p:txBody>
+          <a:bodyPr wrap="square">
+            <a:spAutoFit/>
+          </a:bodyPr>
+          <a:lstStyle/>
+          <a:p>
+            <a:pPr algn="l">
+              <a:lnSpc>
+                <a:spcPct val="100000"/>
+              </a:lnSpc>
+            </a:pPr>
+            <a:r>
+              <a:rPr sz="1300" b="0" i="0">
+                <a:solidFill>
+                  <a:srgbClr val="14161A"/>
+                </a:solidFill>
+                <a:latin typeface="Avenir Next"/>
+              </a:rPr>
+              <a:t>[3]  Imbs, J. and Mejean, I. (2015). Elasticity Optimism. American Economic Journal:</a:t>
+            </a:r>
+          </a:p>
+        </p:txBody>
+      </p:sp>
+      <p:sp>
+        <p:nvSpPr>
+          <p:cNvPr id="10" name="TextBox 9"/>
+          <p:cNvSpPr txBox="1"/>
+          <p:nvPr/>
+        </p:nvSpPr>
+        <p:spPr>
+          <a:xfrm>
+            <a:off x="685800" y="3154679"/>
+            <a:ext cx="10817352" cy="310896"/>
+          </a:xfrm>
+          <a:prstGeom prst="rect">
+            <a:avLst/>
+          </a:prstGeom>
+          <a:noFill/>
+        </p:spPr>
+        <p:txBody>
+          <a:bodyPr wrap="square">
+            <a:spAutoFit/>
+          </a:bodyPr>
+          <a:lstStyle/>
+          <a:p>
+            <a:pPr algn="l">
+              <a:lnSpc>
+                <a:spcPct val="100000"/>
+              </a:lnSpc>
+            </a:pPr>
+            <a:r>
+              <a:rPr sz="1300" b="0" i="0">
+                <a:solidFill>
+                  <a:srgbClr val="6E737C"/>
+                </a:solidFill>
+                <a:latin typeface="Avenir Next"/>
+              </a:rPr>
+              <a:t>       Macroeconomics 7(3), 43-83.</a:t>
+            </a:r>
+          </a:p>
+        </p:txBody>
+      </p:sp>
+      <p:sp>
+        <p:nvSpPr>
+          <p:cNvPr id="11" name="TextBox 10"/>
+          <p:cNvSpPr txBox="1"/>
+          <p:nvPr/>
+        </p:nvSpPr>
+        <p:spPr>
+          <a:xfrm>
+            <a:off x="685800" y="3428999"/>
+            <a:ext cx="10817352" cy="310896"/>
+          </a:xfrm>
+          <a:prstGeom prst="rect">
+            <a:avLst/>
+          </a:prstGeom>
+          <a:noFill/>
+        </p:spPr>
+        <p:txBody>
+          <a:bodyPr wrap="square">
+            <a:spAutoFit/>
+          </a:bodyPr>
+          <a:lstStyle/>
+          <a:p>
+            <a:pPr algn="l">
+              <a:lnSpc>
+                <a:spcPct val="100000"/>
+              </a:lnSpc>
+            </a:pPr>
+            <a:r>
+              <a:rPr sz="1300" b="0" i="0">
+                <a:solidFill>
+                  <a:srgbClr val="14161A"/>
+                </a:solidFill>
+                <a:latin typeface="Avenir Next"/>
+              </a:rPr>
+              <a:t>[4]  Flaaen, A. and Pierce, J. (2019). Disentangling the Effects of the 2018-2019 Tariffs on a</a:t>
+            </a:r>
+          </a:p>
+        </p:txBody>
+      </p:sp>
+      <p:sp>
+        <p:nvSpPr>
+          <p:cNvPr id="12" name="TextBox 11"/>
+          <p:cNvSpPr txBox="1"/>
+          <p:nvPr/>
+        </p:nvSpPr>
+        <p:spPr>
+          <a:xfrm>
+            <a:off x="685800" y="3703319"/>
+            <a:ext cx="10817352" cy="310896"/>
+          </a:xfrm>
+          <a:prstGeom prst="rect">
+            <a:avLst/>
+          </a:prstGeom>
+          <a:noFill/>
+        </p:spPr>
+        <p:txBody>
+          <a:bodyPr wrap="square">
+            <a:spAutoFit/>
+          </a:bodyPr>
+          <a:lstStyle/>
+          <a:p>
+            <a:pPr algn="l">
+              <a:lnSpc>
+                <a:spcPct val="100000"/>
+              </a:lnSpc>
+            </a:pPr>
+            <a:r>
+              <a:rPr sz="1300" b="0" i="0">
+                <a:solidFill>
+                  <a:srgbClr val="6E737C"/>
+                </a:solidFill>
+                <a:latin typeface="Avenir Next"/>
+              </a:rPr>
+              <a:t>       Globally Connected U.S. Manufacturing Sector. Federal Reserve FEDS 2019-086.</a:t>
+            </a:r>
+          </a:p>
+        </p:txBody>
+      </p:sp>
+      <p:sp>
+        <p:nvSpPr>
+          <p:cNvPr id="13" name="TextBox 12"/>
+          <p:cNvSpPr txBox="1"/>
+          <p:nvPr/>
+        </p:nvSpPr>
+        <p:spPr>
+          <a:xfrm>
+            <a:off x="685800" y="3977639"/>
+            <a:ext cx="10817352" cy="310896"/>
+          </a:xfrm>
+          <a:prstGeom prst="rect">
+            <a:avLst/>
+          </a:prstGeom>
+          <a:noFill/>
+        </p:spPr>
+        <p:txBody>
+          <a:bodyPr wrap="square">
+            <a:spAutoFit/>
+          </a:bodyPr>
+          <a:lstStyle/>
+          <a:p>
+            <a:pPr algn="l">
+              <a:lnSpc>
+                <a:spcPct val="100000"/>
+              </a:lnSpc>
+            </a:pPr>
+            <a:r>
+              <a:rPr sz="1300" b="0" i="0">
+                <a:solidFill>
+                  <a:srgbClr val="14161A"/>
+                </a:solidFill>
+                <a:latin typeface="Avenir Next"/>
+              </a:rPr>
+              <a:t>[5]  Khan, S. Y. and Khederlarian, A. (2021). How does trade respond to anticipated tariff</a:t>
+            </a:r>
+          </a:p>
+        </p:txBody>
+      </p:sp>
+      <p:sp>
+        <p:nvSpPr>
+          <p:cNvPr id="14" name="TextBox 13"/>
+          <p:cNvSpPr txBox="1"/>
+          <p:nvPr/>
+        </p:nvSpPr>
+        <p:spPr>
+          <a:xfrm>
+            <a:off x="685800" y="4251959"/>
+            <a:ext cx="10817352" cy="310896"/>
+          </a:xfrm>
+          <a:prstGeom prst="rect">
+            <a:avLst/>
+          </a:prstGeom>
+          <a:noFill/>
+        </p:spPr>
+        <p:txBody>
+          <a:bodyPr wrap="square">
+            <a:spAutoFit/>
+          </a:bodyPr>
+          <a:lstStyle/>
+          <a:p>
+            <a:pPr algn="l">
+              <a:lnSpc>
+                <a:spcPct val="100000"/>
+              </a:lnSpc>
+            </a:pPr>
+            <a:r>
+              <a:rPr sz="1300" b="0" i="0">
+                <a:solidFill>
+                  <a:srgbClr val="6E737C"/>
+                </a:solidFill>
+                <a:latin typeface="Avenir Next"/>
+              </a:rPr>
+              <a:t>       changes? Evidence from NAFTA. Journal of International Economics 133, 103538.</a:t>
+            </a:r>
+          </a:p>
+        </p:txBody>
+      </p:sp>
+      <p:sp>
+        <p:nvSpPr>
+          <p:cNvPr id="15" name="TextBox 14"/>
+          <p:cNvSpPr txBox="1"/>
+          <p:nvPr/>
+        </p:nvSpPr>
+        <p:spPr>
+          <a:xfrm>
+            <a:off x="685800" y="4526279"/>
+            <a:ext cx="10817352" cy="310896"/>
+          </a:xfrm>
+          <a:prstGeom prst="rect">
+            <a:avLst/>
+          </a:prstGeom>
+          <a:noFill/>
+        </p:spPr>
+        <p:txBody>
+          <a:bodyPr wrap="square">
+            <a:spAutoFit/>
+          </a:bodyPr>
+          <a:lstStyle/>
+          <a:p>
+            <a:pPr algn="l">
+              <a:lnSpc>
+                <a:spcPct val="100000"/>
+              </a:lnSpc>
+            </a:pPr>
+            <a:r>
+              <a:rPr sz="1300" b="0" i="0">
+                <a:solidFill>
+                  <a:srgbClr val="14161A"/>
+                </a:solidFill>
+                <a:latin typeface="Avenir Next"/>
+              </a:rPr>
+              <a:t>[6]  Cleveland, R., Cleveland, W., McRae, J. and Terpenning, I. (1990). STL: A seasonal-trend</a:t>
+            </a:r>
+          </a:p>
+        </p:txBody>
+      </p:sp>
+      <p:sp>
+        <p:nvSpPr>
+          <p:cNvPr id="16" name="TextBox 15"/>
+          <p:cNvSpPr txBox="1"/>
+          <p:nvPr/>
+        </p:nvSpPr>
+        <p:spPr>
+          <a:xfrm>
+            <a:off x="685800" y="4800599"/>
+            <a:ext cx="10817352" cy="310896"/>
+          </a:xfrm>
+          <a:prstGeom prst="rect">
+            <a:avLst/>
+          </a:prstGeom>
+          <a:noFill/>
+        </p:spPr>
+        <p:txBody>
+          <a:bodyPr wrap="square">
+            <a:spAutoFit/>
+          </a:bodyPr>
+          <a:lstStyle/>
+          <a:p>
+            <a:pPr algn="l">
+              <a:lnSpc>
+                <a:spcPct val="100000"/>
+              </a:lnSpc>
+            </a:pPr>
+            <a:r>
+              <a:rPr sz="1300" b="0" i="0">
+                <a:solidFill>
+                  <a:srgbClr val="6E737C"/>
+                </a:solidFill>
+                <a:latin typeface="Avenir Next"/>
+              </a:rPr>
+              <a:t>       decomposition procedure based on LOESS. Journal of Official Statistics 6(1), 3-73.</a:t>
+            </a:r>
+          </a:p>
+        </p:txBody>
+      </p:sp>
+      <p:sp>
+        <p:nvSpPr>
+          <p:cNvPr id="17" name="TextBox 16"/>
+          <p:cNvSpPr txBox="1"/>
+          <p:nvPr/>
+        </p:nvSpPr>
+        <p:spPr>
+          <a:xfrm>
+            <a:off x="685800" y="5897880"/>
+            <a:ext cx="10817352" cy="457200"/>
+          </a:xfrm>
+          <a:prstGeom prst="rect">
+            <a:avLst/>
+          </a:prstGeom>
+          <a:noFill/>
+        </p:spPr>
+        <p:txBody>
+          <a:bodyPr wrap="square">
+            <a:spAutoFit/>
+          </a:bodyPr>
+          <a:lstStyle/>
+          <a:p>
+            <a:pPr algn="l">
+              <a:lnSpc>
+                <a:spcPct val="100000"/>
+              </a:lnSpc>
+            </a:pPr>
+            <a:r>
+              <a:rPr sz="1400" b="0" i="0">
+                <a:solidFill>
+                  <a:srgbClr val="6E737C"/>
+                </a:solidFill>
+                <a:latin typeface="Avenir Next"/>
+              </a:rPr>
+              <a:t>Data: US Census international trade API  |  Federal Register API  |  USITC Harmonized Tariff Schedule, chapter 99</a:t>
+            </a:r>
+          </a:p>
+        </p:txBody>
+      </p:sp>
+    </p:spTree>
+  </p:cSld>
+  <p:clrMapOvr>
+    <a:masterClrMapping/>
+  </p:clrMapOvr>
+</p:sld>
+</file>
+
 <file path=ppt/slides/slide2.xml><?xml version="1.0" encoding="utf-8"?>
 <p:sld xmlns:a="http://schemas.openxmlformats.org/drawingml/2006/main" xmlns:p="http://schemas.openxmlformats.org/presentationml/2006/main" xmlns:r="http://schemas.openxmlformats.org/officeDocument/2006/relationships">
   <p:cSld>
@@ -6693,6 +7426,22 @@
                 <a:latin typeface="Avenir Next"/>
               </a:rPr>
               <a:t>Fig. 5   The typical tariff action covers about 5% of its chapter's value. A third cover under 1%.</a:t>
+            </a:r>
+          </a:p>
+          <a:p>
+            <a:pPr algn="l">
+              <a:lnSpc>
+                <a:spcPct val="112000"/>
+              </a:lnSpc>
+            </a:pPr>
+            <a:r>
+              <a:rPr sz="1700" b="0" i="0">
+                <a:solidFill>
+                  <a:srgbClr val="6E737C"/>
+                </a:solidFill>
+                <a:latin typeface="Avenir Next"/>
+              </a:rPr>
+              <a:t>Published work measures these at HS-8 to HS-10 [1]. Coarser data shrinks estimates [2].</a:t>
             </a:r>
           </a:p>
         </p:txBody>

</xml_diff>

<commit_message>
Name Rahul and Raunak in the speaker notes instead of "one of us"
Raunak reads these notes to prepare, and "slides 1-4 one of us, 5-8 the other"
does not tell him which half is his. The split is now named outright, slide 4
carries an explicit handover cue, and slide 5 says Raunak starts there.

Project voice is left alone. "We read the lists", "what happened to us" and
"the number is ours" all include him and should stay first person plural.

Slide 1's notes also pointed at a 9:15 script that is now 9:03; the figure is
read out of SCRIPT.md at build time so it cannot drift again.
</commit_message>
<xml_diff>
--- a/slides/Mandadi_Khalsa_Presentation1.pptx
+++ b/slides/Mandadi_Khalsa_Presentation1.pptx
@@ -512,7 +512,12 @@
           <a:lstStyle/>
           <a:p>
             <a:r>
-              <a:t>SPEAKER SPLIT: slides 1-4 one of us, 5-8 the other. Both must speak.</a:t>
+              <a:t>SPEAKER SPLIT: RAHUL takes slides 1 to 4. RAUNAK takes slides 5 to 8.</a:t>
+            </a:r>
+          </a:p>
+          <a:p>
+            <a:r>
+              <a:t>The rubric requires both of them to speak, so neither half is optional.</a:t>
             </a:r>
           </a:p>
           <a:p>
@@ -522,7 +527,7 @@
           </a:p>
           <a:p>
             <a:r>
-              <a:t>slides/SCRIPT.md is written to 9:15 measured. Do not ad-lib past it.</a:t>
+              <a:t>slides/SCRIPT.md is written to 9:03 measured, which is the whole budget. Do not ad-lib.</a:t>
             </a:r>
           </a:p>
           <a:p>
@@ -1047,6 +1052,12 @@
               <a:t>Say plainly that this presentation is the data and its limits, not answers yet.</a:t>
             </a:r>
           </a:p>
+          <a:p/>
+          <a:p>
+            <a:r>
+              <a:t>RAHUL HANDS OVER HERE. Say Raunak's name out loud so the switch is clean.</a:t>
+            </a:r>
+          </a:p>
         </p:txBody>
       </p:sp>
       <p:sp>
@@ -1114,7 +1125,7 @@
           <a:lstStyle/>
           <a:p>
             <a:r>
-              <a:t>THE DATA. Two things on this slide, go left then right.</a:t>
+              <a:t>THE DATA. RAUNAK STARTS HERE. Two things on this slide, go left then right.</a:t>
             </a:r>
           </a:p>
           <a:p/>

</xml_diff>

<commit_message>
Revert the third mark on Fig. 1
Rahul is presenting the version already on Canvas, so the deck has to match it
rather than be better than it. Talking about a grey line that is not in the PDF
the room is following would cost more than the extra mark gains.

The argument it made visible is still made in words, by the caption and by the
spoken line about the investigation being public months earlier. Nothing is lost
except the picture.

Keeping the two changes from 616d629 that do not depend on it: the leaner slide
1 and saying the copper recovery out loud.

Worth redoing after the presentation. The February order and the March comment
notice are in our index, the climb lines up with them, and that is the cleanest
evidence we have for the claim the deck makes twice.
</commit_message>
<xml_diff>
--- a/slides/Mandadi_Khalsa_Presentation1.pptx
+++ b/slides/Mandadi_Khalsa_Presentation1.pptx
@@ -986,7 +986,7 @@
           <a:lstStyle/>
           <a:p>
             <a:r>
-              <a:t>RAHUL   |   this slide 1:16   |   clock at end 1:36</a:t>
+              <a:t>RAHUL   |   this slide 1:18   |   clock at end 1:38</a:t>
             </a:r>
           </a:p>
           <a:p>
@@ -1013,33 +1013,28 @@
           <a:p/>
           <a:p>
             <a:r>
-              <a:t>Figure 1 is monthly copper imports, with three marks on it. The grey one is February 2025, when</a:t>
-            </a:r>
-          </a:p>
-          <a:p>
-            <a:r>
-              <a:t>the government ordered an investigation. Then July, when a fifty percent duty was announced. Then</a:t>
-            </a:r>
-          </a:p>
-          <a:p>
-            <a:r>
-              <a:t>August, when it started.</a:t>
-            </a:r>
-          </a:p>
-          <a:p/>
-          <a:p>
-            <a:r>
-              <a:t>Now look at where the line turns. It doesn't wait for July. It starts climbing right after the</a:t>
-            </a:r>
-          </a:p>
-          <a:p>
-            <a:r>
-              <a:t>grey line, and nearly triples before the duty is even announced. The investigation was public, so</a:t>
-            </a:r>
-          </a:p>
-          <a:p>
-            <a:r>
-              <a:t>everyone could see it coming.</a:t>
+              <a:t>Figure 1 is monthly copper imports, in dollars. Here's July 2025, when a fifty percent duty was</a:t>
+            </a:r>
+          </a:p>
+          <a:p>
+            <a:r>
+              <a:t>announced. Here's August, when it started. Three weeks apart.</a:t>
+            </a:r>
+          </a:p>
+          <a:p/>
+          <a:p>
+            <a:r>
+              <a:t>But look at what the line does. It doesn't wait for July. It starts climbing in February, and</a:t>
+            </a:r>
+          </a:p>
+          <a:p>
+            <a:r>
+              <a:t>nearly triples by the time of the announcement. Why? Because the investigation behind that tariff</a:t>
+            </a:r>
+          </a:p>
+          <a:p>
+            <a:r>
+              <a:t>was public months earlier. Everyone in the industry could see it coming.</a:t>
             </a:r>
           </a:p>
           <a:p/>
@@ -1068,12 +1063,17 @@
           <a:p/>
           <a:p>
             <a:r>
-              <a:t>That's front-loading. Goods that would have come in October came in June instead. We call that</a:t>
-            </a:r>
-          </a:p>
-          <a:p>
-            <a:r>
-              <a:t>borrowed, because the later months pay it back.</a:t>
+              <a:t>That's front-loading. Goods that would have come in October came in June instead. Nothing got</a:t>
+            </a:r>
+          </a:p>
+          <a:p>
+            <a:r>
+              <a:t>created, it just moved forward in time. We call that borrowed, because the later months pay it</a:t>
+            </a:r>
+          </a:p>
+          <a:p>
+            <a:r>
+              <a:t>back.</a:t>
             </a:r>
           </a:p>
           <a:p/>
@@ -1218,7 +1218,7 @@
           <a:lstStyle/>
           <a:p>
             <a:r>
-              <a:t>RAHUL   |   this slide 1:10   |   clock at end 2:47</a:t>
+              <a:t>RAHUL   |   this slide 1:10   |   clock at end 2:48</a:t>
             </a:r>
           </a:p>
           <a:p>
@@ -1422,7 +1422,7 @@
           <a:lstStyle/>
           <a:p>
             <a:r>
-              <a:t>RAHUL   |   this slide 0:51   |   clock at end 3:38</a:t>
+              <a:t>RAHUL   |   this slide 0:51   |   clock at end 3:40</a:t>
             </a:r>
           </a:p>
           <a:p>
@@ -1604,7 +1604,7 @@
           <a:lstStyle/>
           <a:p>
             <a:r>
-              <a:t>RAUNAK   |   this slide 1:31   |   clock at end 5:10</a:t>
+              <a:t>RAUNAK   |   this slide 1:31   |   clock at end 5:12</a:t>
             </a:r>
           </a:p>
           <a:p>
@@ -1818,7 +1818,7 @@
           <a:lstStyle/>
           <a:p>
             <a:r>
-              <a:t>RAUNAK   |   this slide 1:22   |   clock at end 6:32</a:t>
+              <a:t>RAUNAK   |   this slide 1:22   |   clock at end 6:34</a:t>
             </a:r>
           </a:p>
           <a:p>
@@ -2027,7 +2027,7 @@
           <a:lstStyle/>
           <a:p>
             <a:r>
-              <a:t>RAUNAK   |   this slide 1:48   |   clock at end 8:21</a:t>
+              <a:t>RAUNAK   |   this slide 1:48   |   clock at end 8:23</a:t>
             </a:r>
           </a:p>
           <a:p>
@@ -2297,7 +2297,7 @@
           <a:lstStyle/>
           <a:p>
             <a:r>
-              <a:t>RAUNAK   |   this slide 1:31   |   clock at end 9:53</a:t>
+              <a:t>RAUNAK   |   this slide 1:31   |   clock at end 9:54</a:t>
             </a:r>
           </a:p>
           <a:p>
@@ -6810,8 +6810,8 @@
         </p:blipFill>
         <p:spPr>
           <a:xfrm>
-            <a:off x="1999047" y="1874519"/>
-            <a:ext cx="8193600" cy="3822192"/>
+            <a:off x="1920906" y="1874519"/>
+            <a:ext cx="8349882" cy="3822192"/>
           </a:xfrm>
           <a:prstGeom prst="rect">
             <a:avLst/>
@@ -6852,7 +6852,7 @@
                 </a:solidFill>
                 <a:latin typeface="Avenir Next"/>
               </a:rPr>
-              <a:t>Fig. 1   Copper. Investigation ordered in February, duty announced in July, in force from August.</a:t>
+              <a:t>Fig. 1   Copper imports. Announced July 2025, in force from August.</a:t>
             </a:r>
           </a:p>
           <a:p>
@@ -6868,7 +6868,7 @@
                 </a:solidFill>
                 <a:latin typeface="Avenir Next"/>
               </a:rPr>
-              <a:t>The climb starts at the investigation, not at the announcement.</a:t>
+              <a:t>Imports had been climbing since February, because the duty was expected.</a:t>
             </a:r>
           </a:p>
           <a:p>

</xml_diff>

<commit_message>
Trim slides 2, 5 and 8 to pay for the copper correction
The previous commit added the correction but the trims that were meant to fund
it failed to apply, so it went in at 10:03. Back to 9:50 at 130 words a minute,
8:49 at 145.

Raunak's half drops to 6:11, and his standalone file is regenerated with it.
</commit_message>
<xml_diff>
--- a/slides/Mandadi_Khalsa_Presentation1.pptx
+++ b/slides/Mandadi_Khalsa_Presentation1.pptx
@@ -986,7 +986,7 @@
           <a:lstStyle/>
           <a:p>
             <a:r>
-              <a:t>RAHUL   |   this slide 1:31   |   clock at end 1:51</a:t>
+              <a:t>RAHUL   |   this slide 1:22   |   clock at end 1:42</a:t>
             </a:r>
           </a:p>
           <a:p>
@@ -1024,17 +1024,17 @@
           <a:p/>
           <a:p>
             <a:r>
-              <a:t>But look at what the line does. It doesn't wait for July. It starts climbing in February, and</a:t>
-            </a:r>
-          </a:p>
-          <a:p>
-            <a:r>
-              <a:t>nearly triples by the time of the announcement. Why? Because the investigation behind that tariff</a:t>
-            </a:r>
-          </a:p>
-          <a:p>
-            <a:r>
-              <a:t>was public months earlier. Everyone in the industry could see it coming.</a:t>
+              <a:t>But look at what the line does. It doesn't wait for July. It starts climbing in February and</a:t>
+            </a:r>
+          </a:p>
+          <a:p>
+            <a:r>
+              <a:t>nearly triples by the announcement, because the investigation was public months earlier. Everyone</a:t>
+            </a:r>
+          </a:p>
+          <a:p>
+            <a:r>
+              <a:t>could see it coming.</a:t>
             </a:r>
           </a:p>
           <a:p/>
@@ -1052,22 +1052,22 @@
           <a:p/>
           <a:p>
             <a:r>
-              <a:t>You'll also see it climb back up at the end, and here's why. When the tariff actually landed it</a:t>
-            </a:r>
-          </a:p>
-          <a:p>
-            <a:r>
-              <a:t>covered semi-finished copper, so wire and tube and fittings, not refined cathodes, which are most</a:t>
-            </a:r>
-          </a:p>
-          <a:p>
-            <a:r>
-              <a:t>of this chart. So a lot of that rush was on an expectation that didn't land. The products that did</a:t>
-            </a:r>
-          </a:p>
-          <a:p>
-            <a:r>
-              <a:t>get the fifty percent are down about forty-five percent and have stayed down.</a:t>
+              <a:t>You'll also see it climb back up, and here's why. The tariff landed on semi-finished copper, wire</a:t>
+            </a:r>
+          </a:p>
+          <a:p>
+            <a:r>
+              <a:t>and tube, not on refined cathodes, which are most of this chart. So a lot of that rush was on an</a:t>
+            </a:r>
+          </a:p>
+          <a:p>
+            <a:r>
+              <a:t>expectation that didn't land. The products that did get the fifty percent are down forty-five</a:t>
+            </a:r>
+          </a:p>
+          <a:p>
+            <a:r>
+              <a:t>percent and have stayed down.</a:t>
             </a:r>
           </a:p>
           <a:p/>
@@ -1223,7 +1223,7 @@
           <a:lstStyle/>
           <a:p>
             <a:r>
-              <a:t>RAHUL   |   this slide 1:08   |   clock at end 3:00</a:t>
+              <a:t>RAHUL   |   this slide 1:08   |   clock at end 2:51</a:t>
             </a:r>
           </a:p>
           <a:p>
@@ -1427,7 +1427,7 @@
           <a:lstStyle/>
           <a:p>
             <a:r>
-              <a:t>RAHUL   |   this slide 0:51   |   clock at end 3:51</a:t>
+              <a:t>RAHUL   |   this slide 0:51   |   clock at end 3:42</a:t>
             </a:r>
           </a:p>
           <a:p>
@@ -1609,7 +1609,7 @@
           <a:lstStyle/>
           <a:p>
             <a:r>
-              <a:t>RAUNAK   |   this slide 1:31   |   clock at end 5:23</a:t>
+              <a:t>RAUNAK   |   this slide 1:28   |   clock at end 5:11</a:t>
             </a:r>
           </a:p>
           <a:p>
@@ -1690,12 +1690,12 @@
           <a:p/>
           <a:p>
             <a:r>
-              <a:t>Second source is the Federal Register. We went through nearly two thousand eight hundred</a:t>
-            </a:r>
-          </a:p>
-          <a:p>
-            <a:r>
-              <a:t>documents, and a hundred and thirty four of them are real tariff actions.</a:t>
+              <a:t>Second source is the Federal Register. Nearly two thousand eight hundred documents, a hundred and</a:t>
+            </a:r>
+          </a:p>
+          <a:p>
+            <a:r>
+              <a:t>thirty four real tariff actions.</a:t>
             </a:r>
           </a:p>
           <a:p/>
@@ -1823,7 +1823,7 @@
           <a:lstStyle/>
           <a:p>
             <a:r>
-              <a:t>RAUNAK   |   this slide 1:22   |   clock at end 6:45</a:t>
+              <a:t>RAUNAK   |   this slide 1:22   |   clock at end 6:33</a:t>
             </a:r>
           </a:p>
           <a:p>
@@ -2032,7 +2032,7 @@
           <a:lstStyle/>
           <a:p>
             <a:r>
-              <a:t>RAUNAK   |   this slide 1:46   |   clock at end 8:31</a:t>
+              <a:t>RAUNAK   |   this slide 1:46   |   clock at end 8:19</a:t>
             </a:r>
           </a:p>
           <a:p>
@@ -2297,7 +2297,7 @@
           <a:lstStyle/>
           <a:p>
             <a:r>
-              <a:t>RAUNAK   |   this slide 1:31   |   clock at end 10:03</a:t>
+              <a:t>RAUNAK   |   this slide 1:30   |   clock at end 9:50</a:t>
             </a:r>
           </a:p>
           <a:p>
@@ -2373,7 +2373,7 @@
           <a:p/>
           <a:p>
             <a:r>
-              <a:t>Next, question one first, then two and three for the final report.</a:t>
+              <a:t>Next, question one, then two and three for the final report.</a:t>
             </a:r>
           </a:p>
           <a:p/>

</xml_diff>